<commit_message>
some final tweaks to presentation and passport and .exe of the game
</commit_message>
<xml_diff>
--- a/presentation.pptx
+++ b/presentation.pptx
@@ -4878,13 +4878,13 @@
   <p:clrMapOvr>
     <a:masterClrMapping/>
   </p:clrMapOvr>
-  <mc:AlternateContent xmlns:mc="http://schemas.openxmlformats.org/markup-compatibility/2006">
-    <mc:Choice xmlns:p14="http://schemas.microsoft.com/office/powerpoint/2010/main" Requires="p14">
+  <mc:AlternateContent xmlns:mc="http://schemas.openxmlformats.org/markup-compatibility/2006" xmlns:p14="http://schemas.microsoft.com/office/powerpoint/2010/main">
+    <mc:Choice Requires="p14">
       <p:transition spd="slow">
         <p14:glitter pattern="hexagon"/>
       </p:transition>
     </mc:Choice>
-    <mc:Fallback>
+    <mc:Fallback xmlns="">
       <p:transition spd="slow">
         <p:fade/>
       </p:transition>
@@ -5013,7 +5013,7 @@
                 <a:latin typeface="Arial"/>
                 <a:cs typeface="Arial"/>
               </a:rPr>
-              <a:t>?</a:t>
+              <a:t>Всем кто хочет в неё поиграть</a:t>
             </a:r>
             <a:endParaRPr dirty="0"/>
           </a:p>
@@ -5485,7 +5485,7 @@
                 <a:ea typeface="Times New Roman" panose="02020603050405020304" pitchFamily="18" charset="0"/>
                 <a:cs typeface="Arial" panose="020B0604020202020204" pitchFamily="34" charset="0"/>
               </a:rPr>
-              <a:t>использования </a:t>
+              <a:t>Научиться использовать </a:t>
             </a:r>
             <a:r>
               <a:rPr lang="ru-RU" dirty="0" err="1">
@@ -7038,7 +7038,13 @@
               </a:rPr>
               <a:t>много проблем с отрисовкой</a:t>
             </a:r>
-            <a:endParaRPr dirty="0"/>
+            <a:endParaRPr lang="en-US" dirty="0">
+              <a:solidFill>
+                <a:srgbClr val="07226D"/>
+              </a:solidFill>
+              <a:latin typeface="Arial"/>
+              <a:cs typeface="Arial"/>
+            </a:endParaRPr>
           </a:p>
           <a:p>
             <a:pPr>
@@ -7052,22 +7058,63 @@
                 <a:latin typeface="Arial"/>
                 <a:cs typeface="Arial"/>
               </a:rPr>
-              <a:t>Как их преодолели (поиск в документации, смена алгоритма и т.д.)</a:t>
-            </a:r>
-          </a:p>
-          <a:p>
-            <a:pPr>
-              <a:defRPr/>
-            </a:pPr>
-            <a:r>
-              <a:rPr lang="ru-RU" dirty="0">
+              <a:t>Хотел реализовать систему кнопок как в </a:t>
+            </a:r>
+            <a:r>
+              <a:rPr lang="en-US" dirty="0">
                 <a:solidFill>
                   <a:srgbClr val="07226D"/>
                 </a:solidFill>
                 <a:latin typeface="Arial"/>
                 <a:cs typeface="Arial"/>
               </a:rPr>
+              <a:t>portal</a:t>
+            </a:r>
+            <a:endParaRPr dirty="0"/>
+          </a:p>
+          <a:p>
+            <a:pPr>
+              <a:defRPr/>
+            </a:pPr>
+            <a:r>
+              <a:rPr lang="ru-RU" dirty="0">
+                <a:solidFill>
+                  <a:srgbClr val="07226D"/>
+                </a:solidFill>
+                <a:latin typeface="Arial"/>
+                <a:cs typeface="Arial"/>
+              </a:rPr>
+              <a:t>Как их преодолели (поиск в документации, смена алгоритма и т.д.)</a:t>
+            </a:r>
+          </a:p>
+          <a:p>
+            <a:pPr>
+              <a:defRPr/>
+            </a:pPr>
+            <a:r>
+              <a:rPr lang="ru-RU" dirty="0">
+                <a:solidFill>
+                  <a:srgbClr val="07226D"/>
+                </a:solidFill>
+                <a:latin typeface="Arial"/>
+                <a:cs typeface="Arial"/>
+              </a:rPr>
               <a:t>Починил их</a:t>
+            </a:r>
+          </a:p>
+          <a:p>
+            <a:pPr>
+              <a:defRPr/>
+            </a:pPr>
+            <a:r>
+              <a:rPr lang="ru-RU" dirty="0">
+                <a:solidFill>
+                  <a:srgbClr val="07226D"/>
+                </a:solidFill>
+                <a:latin typeface="Arial"/>
+                <a:cs typeface="Arial"/>
+              </a:rPr>
+              <a:t>Пришлось вырезать</a:t>
             </a:r>
             <a:endParaRPr dirty="0"/>
           </a:p>

</xml_diff>